<commit_message>
Add daily AI news collection: 2026-09-05
</commit_message>
<xml_diff>
--- a/data/2026-09-05.pptx
+++ b/data/2026-09-05.pptx
@@ -3294,7 +3294,7 @@
                   <a:srgbClr val="85C1E9"/>
                 </a:solidFill>
               </a:rPr>
-              <a:t>総収集記事数：210 件</a:t>
+              <a:t>総収集記事数：211 件</a:t>
             </a:r>
           </a:p>
         </p:txBody>
@@ -7723,7 +7723,7 @@
                   <a:srgbClr val="FFFFFF"/>
                 </a:solidFill>
               </a:rPr>
-              <a:t>GPT-6 Astra in code review: Gains, privacy, and cost</a:t>
+              <a:t>【プロンプト公開】他のAIが3日後に知る情報を、Grokは「今」教えてくれる。Grok × Xで技術ニュース収集が完全無料で「週10分」に激変した話</a:t>
             </a:r>
             <a:r>
               <a:rPr sz="900">
@@ -7764,7 +7764,7 @@
                   <a:srgbClr val="E67E22"/>
                 </a:solidFill>
               </a:rPr>
-              <a:t>[HackerNews]  </a:t>
+              <a:t>[Qiita]  </a:t>
             </a:r>
             <a:r>
               <a:rPr sz="800">
@@ -7773,7 +7773,7 @@
                 </a:solidFill>
                 <a:hlinkClick r:id="rId2"/>
               </a:rPr>
-              <a:t>https://www.coderabbit.ai/blog/gpt-6-astra-code-review-evaluation</a:t>
+              <a:t>https://qiita.com/shinkai_/items/dfc92e02ca1c461ead58</a:t>
             </a:r>
           </a:p>
         </p:txBody>
@@ -7806,7 +7806,10 @@
                   <a:srgbClr val="7F8C8D"/>
                 </a:solidFill>
               </a:rPr>
-              <a:t>GPT-6 Astra in code review: Gains, privacy, and cost</a:t>
+              <a:t>はじめに
+AI関連のニュースって、とにかく量が多いですよね。
+毎日のように新しいモデルが発表され、企業の動向がアップデートされ、セキュリティ関連の重大ニュースも次々に流れてきます。  
+そして、そういった情報の「一次情報としての新鮮さ」</a:t>
             </a:r>
           </a:p>
         </p:txBody>
@@ -7847,7 +7850,7 @@
                   <a:srgbClr val="FFFFFF"/>
                 </a:solidFill>
               </a:rPr>
-              <a:t>【第1弾：LLM×音声認識】Nottaが使いにくかったので、Whisper×PyAnnote×Gemini APIで音声文字起こしパイプラインを自作した話</a:t>
+              <a:t>GPT-6 Astra in code review: Gains, privacy, and cost</a:t>
             </a:r>
             <a:r>
               <a:rPr sz="900">
@@ -7855,7 +7858,7 @@
                   <a:srgbClr val="7F8C8D"/>
                 </a:solidFill>
               </a:rPr>
-              <a:t>  (2026-09-04)</a:t>
+              <a:t>  (2026-09-05)</a:t>
             </a:r>
           </a:p>
         </p:txBody>
@@ -7888,6 +7891,130 @@
                   <a:srgbClr val="E67E22"/>
                 </a:solidFill>
               </a:rPr>
+              <a:t>[HackerNews]  </a:t>
+            </a:r>
+            <a:r>
+              <a:rPr sz="800">
+                <a:solidFill>
+                  <a:srgbClr val="5DADE8"/>
+                </a:solidFill>
+                <a:hlinkClick r:id="rId3"/>
+              </a:rPr>
+              <a:t>https://www.coderabbit.ai/blog/gpt-6-astra-code-review-evaluation</a:t>
+            </a:r>
+          </a:p>
+        </p:txBody>
+      </p:sp>
+      <p:sp>
+        <p:nvSpPr>
+          <p:cNvPr id="11" name="TextBox 10"/>
+          <p:cNvSpPr txBox="1"/>
+          <p:nvPr/>
+        </p:nvSpPr>
+        <p:spPr>
+          <a:xfrm>
+            <a:off x="640080" y="3274329"/>
+            <a:ext cx="11155680" cy="427253"/>
+          </a:xfrm>
+          <a:prstGeom prst="rect">
+            <a:avLst/>
+          </a:prstGeom>
+          <a:noFill/>
+        </p:spPr>
+        <p:txBody>
+          <a:bodyPr wrap="square">
+            <a:spAutoFit/>
+          </a:bodyPr>
+          <a:lstStyle/>
+          <a:p>
+            <a:r>
+              <a:rPr sz="900">
+                <a:solidFill>
+                  <a:srgbClr val="7F8C8D"/>
+                </a:solidFill>
+              </a:rPr>
+              <a:t>GPT-6 Astra in code review: Gains, privacy, and cost</a:t>
+            </a:r>
+          </a:p>
+        </p:txBody>
+      </p:sp>
+      <p:sp>
+        <p:nvSpPr>
+          <p:cNvPr id="12" name="TextBox 11"/>
+          <p:cNvSpPr txBox="1"/>
+          <p:nvPr/>
+        </p:nvSpPr>
+        <p:spPr>
+          <a:xfrm>
+            <a:off x="365760" y="3701582"/>
+            <a:ext cx="11430000" cy="569671"/>
+          </a:xfrm>
+          <a:prstGeom prst="rect">
+            <a:avLst/>
+          </a:prstGeom>
+          <a:noFill/>
+        </p:spPr>
+        <p:txBody>
+          <a:bodyPr wrap="square">
+            <a:spAutoFit/>
+          </a:bodyPr>
+          <a:lstStyle/>
+          <a:p>
+            <a:r>
+              <a:rPr sz="1000">
+                <a:solidFill>
+                  <a:srgbClr val="E67E22"/>
+                </a:solidFill>
+              </a:rPr>
+              <a:t>▶ </a:t>
+            </a:r>
+            <a:r>
+              <a:rPr sz="1200" b="1">
+                <a:solidFill>
+                  <a:srgbClr val="FFFFFF"/>
+                </a:solidFill>
+              </a:rPr>
+              <a:t>【第1弾：LLM×音声認識】Nottaが使いにくかったので、Whisper×PyAnnote×Gemini APIで音声文字起こしパイプラインを自作した話</a:t>
+            </a:r>
+            <a:r>
+              <a:rPr sz="900">
+                <a:solidFill>
+                  <a:srgbClr val="7F8C8D"/>
+                </a:solidFill>
+              </a:rPr>
+              <a:t>  (2026-09-04)</a:t>
+            </a:r>
+          </a:p>
+        </p:txBody>
+      </p:sp>
+      <p:sp>
+        <p:nvSpPr>
+          <p:cNvPr id="13" name="TextBox 12"/>
+          <p:cNvSpPr txBox="1"/>
+          <p:nvPr/>
+        </p:nvSpPr>
+        <p:spPr>
+          <a:xfrm>
+            <a:off x="640080" y="4271253"/>
+            <a:ext cx="11155680" cy="341802"/>
+          </a:xfrm>
+          <a:prstGeom prst="rect">
+            <a:avLst/>
+          </a:prstGeom>
+          <a:noFill/>
+        </p:spPr>
+        <p:txBody>
+          <a:bodyPr wrap="none">
+            <a:spAutoFit/>
+          </a:bodyPr>
+          <a:lstStyle/>
+          <a:p>
+            <a:r>
+              <a:rPr sz="800" b="1">
+                <a:solidFill>
+                  <a:srgbClr val="E67E22"/>
+                </a:solidFill>
+              </a:rPr>
               <a:t>[Qiita]  </a:t>
             </a:r>
             <a:r>
@@ -7895,7 +8022,7 @@
                 <a:solidFill>
                   <a:srgbClr val="5DADE8"/>
                 </a:solidFill>
-                <a:hlinkClick r:id="rId3"/>
+                <a:hlinkClick r:id="rId4"/>
               </a:rPr>
               <a:t>https://qiita.com/tool-bizsystems/items/2a6ee711552a50a395a6</a:t>
             </a:r>
@@ -7904,13 +8031,13 @@
       </p:sp>
       <p:sp>
         <p:nvSpPr>
-          <p:cNvPr id="11" name="TextBox 10"/>
-          <p:cNvSpPr txBox="1"/>
-          <p:nvPr/>
-        </p:nvSpPr>
-        <p:spPr>
-          <a:xfrm>
-            <a:off x="640080" y="3274329"/>
+          <p:cNvPr id="14" name="TextBox 13"/>
+          <p:cNvSpPr txBox="1"/>
+          <p:nvPr/>
+        </p:nvSpPr>
+        <p:spPr>
+          <a:xfrm>
+            <a:off x="640080" y="4613056"/>
             <a:ext cx="11155680" cy="427253"/>
           </a:xfrm>
           <a:prstGeom prst="rect">
@@ -7941,13 +8068,13 @@
       </p:sp>
       <p:sp>
         <p:nvSpPr>
-          <p:cNvPr id="12" name="TextBox 11"/>
-          <p:cNvSpPr txBox="1"/>
-          <p:nvPr/>
-        </p:nvSpPr>
-        <p:spPr>
-          <a:xfrm>
-            <a:off x="365760" y="3701582"/>
+          <p:cNvPr id="15" name="TextBox 14"/>
+          <p:cNvSpPr txBox="1"/>
+          <p:nvPr/>
+        </p:nvSpPr>
+        <p:spPr>
+          <a:xfrm>
+            <a:off x="365760" y="5040309"/>
             <a:ext cx="11430000" cy="569671"/>
           </a:xfrm>
           <a:prstGeom prst="rect">
@@ -7990,13 +8117,13 @@
       </p:sp>
       <p:sp>
         <p:nvSpPr>
-          <p:cNvPr id="13" name="TextBox 12"/>
-          <p:cNvSpPr txBox="1"/>
-          <p:nvPr/>
-        </p:nvSpPr>
-        <p:spPr>
-          <a:xfrm>
-            <a:off x="640080" y="4271253"/>
+          <p:cNvPr id="16" name="TextBox 15"/>
+          <p:cNvSpPr txBox="1"/>
+          <p:nvPr/>
+        </p:nvSpPr>
+        <p:spPr>
+          <a:xfrm>
+            <a:off x="640080" y="5609981"/>
             <a:ext cx="11155680" cy="341802"/>
           </a:xfrm>
           <a:prstGeom prst="rect">
@@ -8023,7 +8150,7 @@
                 <a:solidFill>
                   <a:srgbClr val="5DADE8"/>
                 </a:solidFill>
-                <a:hlinkClick r:id="rId4"/>
+                <a:hlinkClick r:id="rId5"/>
               </a:rPr>
               <a:t>https://zenn.dev/ykbone/articles/202609-prompt-injection</a:t>
             </a:r>
@@ -8032,13 +8159,13 @@
       </p:sp>
       <p:sp>
         <p:nvSpPr>
-          <p:cNvPr id="14" name="TextBox 13"/>
-          <p:cNvSpPr txBox="1"/>
-          <p:nvPr/>
-        </p:nvSpPr>
-        <p:spPr>
-          <a:xfrm>
-            <a:off x="640080" y="4613056"/>
+          <p:cNvPr id="17" name="TextBox 16"/>
+          <p:cNvSpPr txBox="1"/>
+          <p:nvPr/>
+        </p:nvSpPr>
+        <p:spPr>
+          <a:xfrm>
+            <a:off x="640080" y="5951783"/>
             <a:ext cx="11155680" cy="427253"/>
           </a:xfrm>
           <a:prstGeom prst="rect">
@@ -8062,132 +8189,6 @@
 AIエディタやチャットAIに、こんなお願いをしたことはありませんか。
 このURLの記事を読んで、要約して
 私もやったことがあります。ある勉強会にて「その操作が情報漏洩の入り口になりうる」と聞いて、正直ぴんと来ませんでした。読ま</a:t>
-            </a:r>
-          </a:p>
-        </p:txBody>
-      </p:sp>
-      <p:sp>
-        <p:nvSpPr>
-          <p:cNvPr id="15" name="TextBox 14"/>
-          <p:cNvSpPr txBox="1"/>
-          <p:nvPr/>
-        </p:nvSpPr>
-        <p:spPr>
-          <a:xfrm>
-            <a:off x="365760" y="5040309"/>
-            <a:ext cx="11430000" cy="569671"/>
-          </a:xfrm>
-          <a:prstGeom prst="rect">
-            <a:avLst/>
-          </a:prstGeom>
-          <a:noFill/>
-        </p:spPr>
-        <p:txBody>
-          <a:bodyPr wrap="square">
-            <a:spAutoFit/>
-          </a:bodyPr>
-          <a:lstStyle/>
-          <a:p>
-            <a:r>
-              <a:rPr sz="1000">
-                <a:solidFill>
-                  <a:srgbClr val="E67E22"/>
-                </a:solidFill>
-              </a:rPr>
-              <a:t>▶ </a:t>
-            </a:r>
-            <a:r>
-              <a:rPr sz="1200" b="1">
-                <a:solidFill>
-                  <a:srgbClr val="FFFFFF"/>
-                </a:solidFill>
-              </a:rPr>
-              <a:t>ChatGPT・Copilot・Gemini… 業務視点でどう選べるか？ ChatAI 13 製品を「8つの独自指標」で比較してみた｜中小企業・管理職のための導…</a:t>
-            </a:r>
-            <a:r>
-              <a:rPr sz="900">
-                <a:solidFill>
-                  <a:srgbClr val="7F8C8D"/>
-                </a:solidFill>
-              </a:rPr>
-              <a:t>  (2026-09-04)</a:t>
-            </a:r>
-          </a:p>
-        </p:txBody>
-      </p:sp>
-      <p:sp>
-        <p:nvSpPr>
-          <p:cNvPr id="16" name="TextBox 15"/>
-          <p:cNvSpPr txBox="1"/>
-          <p:nvPr/>
-        </p:nvSpPr>
-        <p:spPr>
-          <a:xfrm>
-            <a:off x="640080" y="5609981"/>
-            <a:ext cx="11155680" cy="341802"/>
-          </a:xfrm>
-          <a:prstGeom prst="rect">
-            <a:avLst/>
-          </a:prstGeom>
-          <a:noFill/>
-        </p:spPr>
-        <p:txBody>
-          <a:bodyPr wrap="none">
-            <a:spAutoFit/>
-          </a:bodyPr>
-          <a:lstStyle/>
-          <a:p>
-            <a:r>
-              <a:rPr sz="800" b="1">
-                <a:solidFill>
-                  <a:srgbClr val="E67E22"/>
-                </a:solidFill>
-              </a:rPr>
-              <a:t>[Qiita]  </a:t>
-            </a:r>
-            <a:r>
-              <a:rPr sz="800">
-                <a:solidFill>
-                  <a:srgbClr val="5DADE8"/>
-                </a:solidFill>
-                <a:hlinkClick r:id="rId5"/>
-              </a:rPr>
-              <a:t>https://qiita.com/songchong/items/78a9d9c28506ff90d331</a:t>
-            </a:r>
-          </a:p>
-        </p:txBody>
-      </p:sp>
-      <p:sp>
-        <p:nvSpPr>
-          <p:cNvPr id="17" name="TextBox 16"/>
-          <p:cNvSpPr txBox="1"/>
-          <p:nvPr/>
-        </p:nvSpPr>
-        <p:spPr>
-          <a:xfrm>
-            <a:off x="640080" y="5951783"/>
-            <a:ext cx="11155680" cy="427253"/>
-          </a:xfrm>
-          <a:prstGeom prst="rect">
-            <a:avLst/>
-          </a:prstGeom>
-          <a:noFill/>
-        </p:spPr>
-        <p:txBody>
-          <a:bodyPr wrap="square">
-            <a:spAutoFit/>
-          </a:bodyPr>
-          <a:lstStyle/>
-          <a:p>
-            <a:r>
-              <a:rPr sz="900">
-                <a:solidFill>
-                  <a:srgbClr val="7F8C8D"/>
-                </a:solidFill>
-              </a:rPr>
-              <a:t>&gt; 「ChatGPT を会社で使って、情報漏洩や著作権は本当に大丈夫なのか？」
-&gt; 「Microsoft 365 Copilot や Gemini も聞くが、うちの業務で本当に役立つのはどれだ？」
-&gt; 「無料版や個人版のまま社員に使わせてい</a:t>
             </a:r>
           </a:p>
         </p:txBody>
@@ -8409,7 +8410,7 @@
                   <a:srgbClr val="FFFFFF"/>
                 </a:solidFill>
               </a:rPr>
-              <a:t>AIセキュリティ何から勉強すりゃええの？その4</a:t>
+              <a:t>ChatGPT・Copilot・Gemini… 業務視点でどう選べるか？ ChatAI 13 製品を「8つの独自指標」で比較してみた｜中小企業・管理職のための導…</a:t>
             </a:r>
             <a:r>
               <a:rPr sz="900">
@@ -8417,7 +8418,7 @@
                   <a:srgbClr val="7F8C8D"/>
                 </a:solidFill>
               </a:rPr>
-              <a:t>  (2026-08-30)</a:t>
+              <a:t>  (2026-09-04)</a:t>
             </a:r>
           </a:p>
         </p:txBody>
@@ -8459,6 +8460,132 @@
                 </a:solidFill>
                 <a:hlinkClick r:id="rId2"/>
               </a:rPr>
+              <a:t>https://qiita.com/songchong/items/78a9d9c28506ff90d331</a:t>
+            </a:r>
+          </a:p>
+        </p:txBody>
+      </p:sp>
+      <p:sp>
+        <p:nvSpPr>
+          <p:cNvPr id="8" name="TextBox 7"/>
+          <p:cNvSpPr txBox="1"/>
+          <p:nvPr/>
+        </p:nvSpPr>
+        <p:spPr>
+          <a:xfrm>
+            <a:off x="640080" y="1935601"/>
+            <a:ext cx="11155680" cy="427253"/>
+          </a:xfrm>
+          <a:prstGeom prst="rect">
+            <a:avLst/>
+          </a:prstGeom>
+          <a:noFill/>
+        </p:spPr>
+        <p:txBody>
+          <a:bodyPr wrap="square">
+            <a:spAutoFit/>
+          </a:bodyPr>
+          <a:lstStyle/>
+          <a:p>
+            <a:r>
+              <a:rPr sz="900">
+                <a:solidFill>
+                  <a:srgbClr val="7F8C8D"/>
+                </a:solidFill>
+              </a:rPr>
+              <a:t>&gt; 「ChatGPT を会社で使って、情報漏洩や著作権は本当に大丈夫なのか？」
+&gt; 「Microsoft 365 Copilot や Gemini も聞くが、うちの業務で本当に役立つのはどれだ？」
+&gt; 「無料版や個人版のまま社員に使わせてい</a:t>
+            </a:r>
+          </a:p>
+        </p:txBody>
+      </p:sp>
+      <p:sp>
+        <p:nvSpPr>
+          <p:cNvPr id="9" name="TextBox 8"/>
+          <p:cNvSpPr txBox="1"/>
+          <p:nvPr/>
+        </p:nvSpPr>
+        <p:spPr>
+          <a:xfrm>
+            <a:off x="365760" y="2362855"/>
+            <a:ext cx="11430000" cy="569671"/>
+          </a:xfrm>
+          <a:prstGeom prst="rect">
+            <a:avLst/>
+          </a:prstGeom>
+          <a:noFill/>
+        </p:spPr>
+        <p:txBody>
+          <a:bodyPr wrap="square">
+            <a:spAutoFit/>
+          </a:bodyPr>
+          <a:lstStyle/>
+          <a:p>
+            <a:r>
+              <a:rPr sz="1000">
+                <a:solidFill>
+                  <a:srgbClr val="E67E22"/>
+                </a:solidFill>
+              </a:rPr>
+              <a:t>▶ </a:t>
+            </a:r>
+            <a:r>
+              <a:rPr sz="1200" b="1">
+                <a:solidFill>
+                  <a:srgbClr val="FFFFFF"/>
+                </a:solidFill>
+              </a:rPr>
+              <a:t>AIセキュリティ何から勉強すりゃええの？その4</a:t>
+            </a:r>
+            <a:r>
+              <a:rPr sz="900">
+                <a:solidFill>
+                  <a:srgbClr val="7F8C8D"/>
+                </a:solidFill>
+              </a:rPr>
+              <a:t>  (2026-08-30)</a:t>
+            </a:r>
+          </a:p>
+        </p:txBody>
+      </p:sp>
+      <p:sp>
+        <p:nvSpPr>
+          <p:cNvPr id="10" name="TextBox 9"/>
+          <p:cNvSpPr txBox="1"/>
+          <p:nvPr/>
+        </p:nvSpPr>
+        <p:spPr>
+          <a:xfrm>
+            <a:off x="640080" y="2932526"/>
+            <a:ext cx="11155680" cy="341802"/>
+          </a:xfrm>
+          <a:prstGeom prst="rect">
+            <a:avLst/>
+          </a:prstGeom>
+          <a:noFill/>
+        </p:spPr>
+        <p:txBody>
+          <a:bodyPr wrap="none">
+            <a:spAutoFit/>
+          </a:bodyPr>
+          <a:lstStyle/>
+          <a:p>
+            <a:r>
+              <a:rPr sz="800" b="1">
+                <a:solidFill>
+                  <a:srgbClr val="E67E22"/>
+                </a:solidFill>
+              </a:rPr>
+              <a:t>[Qiita]  </a:t>
+            </a:r>
+            <a:r>
+              <a:rPr sz="800">
+                <a:solidFill>
+                  <a:srgbClr val="5DADE8"/>
+                </a:solidFill>
+                <a:hlinkClick r:id="rId3"/>
+              </a:rPr>
               <a:t>https://qiita.com/mikihitooooo/items/d43a58615e948002d70b</a:t>
             </a:r>
           </a:p>
@@ -8466,13 +8593,13 @@
       </p:sp>
       <p:sp>
         <p:nvSpPr>
-          <p:cNvPr id="8" name="TextBox 7"/>
-          <p:cNvSpPr txBox="1"/>
-          <p:nvPr/>
-        </p:nvSpPr>
-        <p:spPr>
-          <a:xfrm>
-            <a:off x="640080" y="1935601"/>
+          <p:cNvPr id="11" name="TextBox 10"/>
+          <p:cNvSpPr txBox="1"/>
+          <p:nvPr/>
+        </p:nvSpPr>
+        <p:spPr>
+          <a:xfrm>
+            <a:off x="640080" y="3274329"/>
             <a:ext cx="11155680" cy="427253"/>
           </a:xfrm>
           <a:prstGeom prst="rect">
@@ -10991,7 +11118,7 @@
                             <a:srgbClr val="D0E4F7"/>
                           </a:solidFill>
                         </a:rPr>
-                        <a:t>4.4%</a:t>
+                        <a:t>4.3%</a:t>
                       </a:r>
                     </a:p>
                   </a:txBody>
@@ -11127,7 +11254,7 @@
                             <a:srgbClr val="D0E4F7"/>
                           </a:solidFill>
                         </a:rPr>
-                        <a:t>32.9%</a:t>
+                        <a:t>32.8%</a:t>
                       </a:r>
                     </a:p>
                   </a:txBody>
@@ -11241,7 +11368,7 @@
                             <a:srgbClr val="E67E22"/>
                           </a:solidFill>
                         </a:rPr>
-                        <a:t>15 件</a:t>
+                        <a:t>16 件</a:t>
                       </a:r>
                     </a:p>
                   </a:txBody>
@@ -11263,7 +11390,7 @@
                             <a:srgbClr val="D0E4F7"/>
                           </a:solidFill>
                         </a:rPr>
-                        <a:t>6.0%</a:t>
+                        <a:t>6.3%</a:t>
                       </a:r>
                     </a:p>
                   </a:txBody>
@@ -11331,7 +11458,7 @@
                             <a:srgbClr val="D0E4F7"/>
                           </a:solidFill>
                         </a:rPr>
-                        <a:t>32.9%</a:t>
+                        <a:t>32.8%</a:t>
                       </a:r>
                     </a:p>
                   </a:txBody>
@@ -11377,7 +11504,7 @@
                             <a:srgbClr val="FFFFFF"/>
                           </a:solidFill>
                         </a:rPr>
-                        <a:t>252 件</a:t>
+                        <a:t>253 件</a:t>
                       </a:r>
                     </a:p>
                   </a:txBody>
@@ -20389,7 +20516,7 @@
                   <a:srgbClr val="E67E22"/>
                 </a:solidFill>
               </a:rPr>
-              <a:t>[HackerNews]  </a:t>
+              <a:t>[Qiita]  </a:t>
             </a:r>
             <a:r>
               <a:rPr sz="1200" b="1">
@@ -20397,7 +20524,7 @@
                   <a:srgbClr val="FFFFFF"/>
                 </a:solidFill>
               </a:rPr>
-              <a:t>GPT-6 Astra in code review: Gains, privacy, and cost</a:t>
+              <a:t>【プロンプト公開】他のAIが3日後に知る情報を、Grokは「今」教えてくれる。Grok × Xで技術ニュース収集が完全無料で「週10分」に激変した話</a:t>
             </a:r>
             <a:r>
               <a:rPr sz="900">
@@ -20439,7 +20566,7 @@
                 </a:solidFill>
                 <a:hlinkClick r:id="rId2"/>
               </a:rPr>
-              <a:t>https://www.coderabbit.ai/blog/gpt-6-astra-code-review-evaluation</a:t>
+              <a:t>https://qiita.com/shinkai_/items/dfc92e02ca1c461ead58</a:t>
             </a:r>
           </a:p>
         </p:txBody>
@@ -20472,7 +20599,10 @@
                   <a:srgbClr val="C0D8F0"/>
                 </a:solidFill>
               </a:rPr>
-              <a:t>GPT-6 Astra in code review: Gains, privacy, and cost</a:t>
+              <a:t>はじめに
+AI関連のニュースって、とにかく量が多いですよね。
+毎日のように新しいモデルが発表され、企業の動向がアップデートされ、セキュリティ関連の重大ニュースも次々に流れてきます。  
+そして、そういった情報の「一次情報としての新鮮さ」で言うと、圧倒的に強いのはXです。ニュースメディアが記事化す</a:t>
             </a:r>
           </a:p>
         </p:txBody>
@@ -20591,7 +20721,7 @@
                   <a:srgbClr val="E67E22"/>
                 </a:solidFill>
               </a:rPr>
-              <a:t>[Qiita]  </a:t>
+              <a:t>[HackerNews]  </a:t>
             </a:r>
             <a:r>
               <a:rPr sz="1200" b="1">
@@ -20599,7 +20729,7 @@
                   <a:srgbClr val="FFFFFF"/>
                 </a:solidFill>
               </a:rPr>
-              <a:t>【第1弾：LLM×音声認識】Nottaが使いにくかったので、Whisper×PyAnnote×Gemini APIで音声文字起こしパイプラインを自作した話</a:t>
+              <a:t>GPT-6 Astra in code review: Gains, privacy, and cost</a:t>
             </a:r>
             <a:r>
               <a:rPr sz="900">
@@ -20607,7 +20737,7 @@
                   <a:srgbClr val="7F8C8D"/>
                 </a:solidFill>
               </a:rPr>
-              <a:t>  (2026-09-04)</a:t>
+              <a:t>  (2026-09-05)</a:t>
             </a:r>
           </a:p>
         </p:txBody>
@@ -20641,6 +20771,208 @@
                 </a:solidFill>
                 <a:hlinkClick r:id="rId3"/>
               </a:rPr>
+              <a:t>https://www.coderabbit.ai/blog/gpt-6-astra-code-review-evaluation</a:t>
+            </a:r>
+          </a:p>
+        </p:txBody>
+      </p:sp>
+      <p:sp>
+        <p:nvSpPr>
+          <p:cNvPr id="16" name="TextBox 15"/>
+          <p:cNvSpPr txBox="1"/>
+          <p:nvPr/>
+        </p:nvSpPr>
+        <p:spPr>
+          <a:xfrm>
+            <a:off x="502920" y="4056888"/>
+            <a:ext cx="11247120" cy="762000"/>
+          </a:xfrm>
+          <a:prstGeom prst="rect">
+            <a:avLst/>
+          </a:prstGeom>
+          <a:noFill/>
+        </p:spPr>
+        <p:txBody>
+          <a:bodyPr wrap="square">
+            <a:spAutoFit/>
+          </a:bodyPr>
+          <a:lstStyle/>
+          <a:p>
+            <a:r>
+              <a:rPr sz="900">
+                <a:solidFill>
+                  <a:srgbClr val="C0D8F0"/>
+                </a:solidFill>
+              </a:rPr>
+              <a:t>GPT-6 Astra in code review: Gains, privacy, and cost</a:t>
+            </a:r>
+          </a:p>
+        </p:txBody>
+      </p:sp>
+      <p:sp>
+        <p:nvSpPr>
+          <p:cNvPr id="17" name="Rectangle 16"/>
+          <p:cNvSpPr/>
+          <p:nvPr/>
+        </p:nvSpPr>
+        <p:spPr>
+          <a:xfrm>
+            <a:off x="274320" y="4916423"/>
+            <a:ext cx="11640312" cy="1795272"/>
+          </a:xfrm>
+          <a:prstGeom prst="rect">
+            <a:avLst/>
+          </a:prstGeom>
+          <a:solidFill>
+            <a:srgbClr val="1E2D47"/>
+          </a:solidFill>
+          <a:ln>
+            <a:noFill/>
+          </a:ln>
+        </p:spPr>
+        <p:style>
+          <a:lnRef idx="1">
+            <a:schemeClr val="accent1"/>
+          </a:lnRef>
+          <a:fillRef idx="3">
+            <a:schemeClr val="accent1"/>
+          </a:fillRef>
+          <a:effectRef idx="2">
+            <a:schemeClr val="accent1"/>
+          </a:effectRef>
+          <a:fontRef idx="minor">
+            <a:schemeClr val="lt1"/>
+          </a:fontRef>
+        </p:style>
+        <p:txBody>
+          <a:bodyPr rtlCol="0" anchor="ctr"/>
+          <a:lstStyle/>
+          <a:p>
+            <a:pPr algn="ctr"/>
+          </a:p>
+        </p:txBody>
+      </p:sp>
+      <p:sp>
+        <p:nvSpPr>
+          <p:cNvPr id="18" name="Rectangle 17"/>
+          <p:cNvSpPr/>
+          <p:nvPr/>
+        </p:nvSpPr>
+        <p:spPr>
+          <a:xfrm>
+            <a:off x="274320" y="4916423"/>
+            <a:ext cx="64008" cy="1795272"/>
+          </a:xfrm>
+          <a:prstGeom prst="rect">
+            <a:avLst/>
+          </a:prstGeom>
+          <a:solidFill>
+            <a:srgbClr val="E67E22"/>
+          </a:solidFill>
+          <a:ln>
+            <a:noFill/>
+          </a:ln>
+        </p:spPr>
+        <p:style>
+          <a:lnRef idx="1">
+            <a:schemeClr val="accent1"/>
+          </a:lnRef>
+          <a:fillRef idx="3">
+            <a:schemeClr val="accent1"/>
+          </a:fillRef>
+          <a:effectRef idx="2">
+            <a:schemeClr val="accent1"/>
+          </a:effectRef>
+          <a:fontRef idx="minor">
+            <a:schemeClr val="lt1"/>
+          </a:fontRef>
+        </p:style>
+        <p:txBody>
+          <a:bodyPr rtlCol="0" anchor="ctr"/>
+          <a:lstStyle/>
+          <a:p>
+            <a:pPr algn="ctr"/>
+          </a:p>
+        </p:txBody>
+      </p:sp>
+      <p:sp>
+        <p:nvSpPr>
+          <p:cNvPr id="19" name="TextBox 18"/>
+          <p:cNvSpPr txBox="1"/>
+          <p:nvPr/>
+        </p:nvSpPr>
+        <p:spPr>
+          <a:xfrm>
+            <a:off x="502920" y="4971288"/>
+            <a:ext cx="11247120" cy="590550"/>
+          </a:xfrm>
+          <a:prstGeom prst="rect">
+            <a:avLst/>
+          </a:prstGeom>
+          <a:noFill/>
+        </p:spPr>
+        <p:txBody>
+          <a:bodyPr wrap="square">
+            <a:spAutoFit/>
+          </a:bodyPr>
+          <a:lstStyle/>
+          <a:p>
+            <a:r>
+              <a:rPr sz="900" b="1">
+                <a:solidFill>
+                  <a:srgbClr val="E67E22"/>
+                </a:solidFill>
+              </a:rPr>
+              <a:t>[Qiita]  </a:t>
+            </a:r>
+            <a:r>
+              <a:rPr sz="1200" b="1">
+                <a:solidFill>
+                  <a:srgbClr val="FFFFFF"/>
+                </a:solidFill>
+              </a:rPr>
+              <a:t>【第1弾：LLM×音声認識】Nottaが使いにくかったので、Whisper×PyAnnote×Gemini APIで音声文字起こしパイプラインを自作した話</a:t>
+            </a:r>
+            <a:r>
+              <a:rPr sz="900">
+                <a:solidFill>
+                  <a:srgbClr val="7F8C8D"/>
+                </a:solidFill>
+              </a:rPr>
+              <a:t>  (2026-09-04)</a:t>
+            </a:r>
+          </a:p>
+        </p:txBody>
+      </p:sp>
+      <p:sp>
+        <p:nvSpPr>
+          <p:cNvPr id="20" name="TextBox 19"/>
+          <p:cNvSpPr txBox="1"/>
+          <p:nvPr/>
+        </p:nvSpPr>
+        <p:spPr>
+          <a:xfrm>
+            <a:off x="502920" y="5561838"/>
+            <a:ext cx="11247120" cy="400050"/>
+          </a:xfrm>
+          <a:prstGeom prst="rect">
+            <a:avLst/>
+          </a:prstGeom>
+          <a:noFill/>
+        </p:spPr>
+        <p:txBody>
+          <a:bodyPr wrap="none">
+            <a:spAutoFit/>
+          </a:bodyPr>
+          <a:lstStyle/>
+          <a:p>
+            <a:r>
+              <a:rPr sz="800">
+                <a:solidFill>
+                  <a:srgbClr val="5DADE8"/>
+                </a:solidFill>
+                <a:hlinkClick r:id="rId4"/>
+              </a:rPr>
               <a:t>https://qiita.com/tool-bizsystems/items/2a6ee711552a50a395a6</a:t>
             </a:r>
           </a:p>
@@ -20648,13 +20980,13 @@
       </p:sp>
       <p:sp>
         <p:nvSpPr>
-          <p:cNvPr id="16" name="TextBox 15"/>
-          <p:cNvSpPr txBox="1"/>
-          <p:nvPr/>
-        </p:nvSpPr>
-        <p:spPr>
-          <a:xfrm>
-            <a:off x="502920" y="4056888"/>
+          <p:cNvPr id="21" name="TextBox 20"/>
+          <p:cNvSpPr txBox="1"/>
+          <p:nvPr/>
+        </p:nvSpPr>
+        <p:spPr>
+          <a:xfrm>
+            <a:off x="502920" y="5961888"/>
             <a:ext cx="11247120" cy="762000"/>
           </a:xfrm>
           <a:prstGeom prst="rect">
@@ -20680,212 +21012,6 @@
  月間利用時間の制限
 - 完全クラウド依存によるプライバシーや仕様変更への不安
 こうした制約を解消す</a:t>
-            </a:r>
-          </a:p>
-        </p:txBody>
-      </p:sp>
-      <p:sp>
-        <p:nvSpPr>
-          <p:cNvPr id="17" name="Rectangle 16"/>
-          <p:cNvSpPr/>
-          <p:nvPr/>
-        </p:nvSpPr>
-        <p:spPr>
-          <a:xfrm>
-            <a:off x="274320" y="4916423"/>
-            <a:ext cx="11640312" cy="1795272"/>
-          </a:xfrm>
-          <a:prstGeom prst="rect">
-            <a:avLst/>
-          </a:prstGeom>
-          <a:solidFill>
-            <a:srgbClr val="1E2D47"/>
-          </a:solidFill>
-          <a:ln>
-            <a:noFill/>
-          </a:ln>
-        </p:spPr>
-        <p:style>
-          <a:lnRef idx="1">
-            <a:schemeClr val="accent1"/>
-          </a:lnRef>
-          <a:fillRef idx="3">
-            <a:schemeClr val="accent1"/>
-          </a:fillRef>
-          <a:effectRef idx="2">
-            <a:schemeClr val="accent1"/>
-          </a:effectRef>
-          <a:fontRef idx="minor">
-            <a:schemeClr val="lt1"/>
-          </a:fontRef>
-        </p:style>
-        <p:txBody>
-          <a:bodyPr rtlCol="0" anchor="ctr"/>
-          <a:lstStyle/>
-          <a:p>
-            <a:pPr algn="ctr"/>
-          </a:p>
-        </p:txBody>
-      </p:sp>
-      <p:sp>
-        <p:nvSpPr>
-          <p:cNvPr id="18" name="Rectangle 17"/>
-          <p:cNvSpPr/>
-          <p:nvPr/>
-        </p:nvSpPr>
-        <p:spPr>
-          <a:xfrm>
-            <a:off x="274320" y="4916423"/>
-            <a:ext cx="64008" cy="1795272"/>
-          </a:xfrm>
-          <a:prstGeom prst="rect">
-            <a:avLst/>
-          </a:prstGeom>
-          <a:solidFill>
-            <a:srgbClr val="E67E22"/>
-          </a:solidFill>
-          <a:ln>
-            <a:noFill/>
-          </a:ln>
-        </p:spPr>
-        <p:style>
-          <a:lnRef idx="1">
-            <a:schemeClr val="accent1"/>
-          </a:lnRef>
-          <a:fillRef idx="3">
-            <a:schemeClr val="accent1"/>
-          </a:fillRef>
-          <a:effectRef idx="2">
-            <a:schemeClr val="accent1"/>
-          </a:effectRef>
-          <a:fontRef idx="minor">
-            <a:schemeClr val="lt1"/>
-          </a:fontRef>
-        </p:style>
-        <p:txBody>
-          <a:bodyPr rtlCol="0" anchor="ctr"/>
-          <a:lstStyle/>
-          <a:p>
-            <a:pPr algn="ctr"/>
-          </a:p>
-        </p:txBody>
-      </p:sp>
-      <p:sp>
-        <p:nvSpPr>
-          <p:cNvPr id="19" name="TextBox 18"/>
-          <p:cNvSpPr txBox="1"/>
-          <p:nvPr/>
-        </p:nvSpPr>
-        <p:spPr>
-          <a:xfrm>
-            <a:off x="502920" y="4971288"/>
-            <a:ext cx="11247120" cy="590550"/>
-          </a:xfrm>
-          <a:prstGeom prst="rect">
-            <a:avLst/>
-          </a:prstGeom>
-          <a:noFill/>
-        </p:spPr>
-        <p:txBody>
-          <a:bodyPr wrap="square">
-            <a:spAutoFit/>
-          </a:bodyPr>
-          <a:lstStyle/>
-          <a:p>
-            <a:r>
-              <a:rPr sz="900" b="1">
-                <a:solidFill>
-                  <a:srgbClr val="E67E22"/>
-                </a:solidFill>
-              </a:rPr>
-              <a:t>[Zenn]  </a:t>
-            </a:r>
-            <a:r>
-              <a:rPr sz="1200" b="1">
-                <a:solidFill>
-                  <a:srgbClr val="FFFFFF"/>
-                </a:solidFill>
-              </a:rPr>
-              <a:t>【プロンプトインジェクション】AI時代の「見えない指示」の落とし穴</a:t>
-            </a:r>
-            <a:r>
-              <a:rPr sz="900">
-                <a:solidFill>
-                  <a:srgbClr val="7F8C8D"/>
-                </a:solidFill>
-              </a:rPr>
-              <a:t>  (2026-09-04)</a:t>
-            </a:r>
-          </a:p>
-        </p:txBody>
-      </p:sp>
-      <p:sp>
-        <p:nvSpPr>
-          <p:cNvPr id="20" name="TextBox 19"/>
-          <p:cNvSpPr txBox="1"/>
-          <p:nvPr/>
-        </p:nvSpPr>
-        <p:spPr>
-          <a:xfrm>
-            <a:off x="502920" y="5561838"/>
-            <a:ext cx="11247120" cy="400050"/>
-          </a:xfrm>
-          <a:prstGeom prst="rect">
-            <a:avLst/>
-          </a:prstGeom>
-          <a:noFill/>
-        </p:spPr>
-        <p:txBody>
-          <a:bodyPr wrap="none">
-            <a:spAutoFit/>
-          </a:bodyPr>
-          <a:lstStyle/>
-          <a:p>
-            <a:r>
-              <a:rPr sz="800">
-                <a:solidFill>
-                  <a:srgbClr val="5DADE8"/>
-                </a:solidFill>
-                <a:hlinkClick r:id="rId4"/>
-              </a:rPr>
-              <a:t>https://zenn.dev/ykbone/articles/202609-prompt-injection</a:t>
-            </a:r>
-          </a:p>
-        </p:txBody>
-      </p:sp>
-      <p:sp>
-        <p:nvSpPr>
-          <p:cNvPr id="21" name="TextBox 20"/>
-          <p:cNvSpPr txBox="1"/>
-          <p:nvPr/>
-        </p:nvSpPr>
-        <p:spPr>
-          <a:xfrm>
-            <a:off x="502920" y="5961888"/>
-            <a:ext cx="11247120" cy="762000"/>
-          </a:xfrm>
-          <a:prstGeom prst="rect">
-            <a:avLst/>
-          </a:prstGeom>
-          <a:noFill/>
-        </p:spPr>
-        <p:txBody>
-          <a:bodyPr wrap="square">
-            <a:spAutoFit/>
-          </a:bodyPr>
-          <a:lstStyle/>
-          <a:p>
-            <a:r>
-              <a:rPr sz="900">
-                <a:solidFill>
-                  <a:srgbClr val="C0D8F0"/>
-                </a:solidFill>
-              </a:rPr>
-              <a:t>はじめに
-AIエディタやチャットAIに、こんなお願いをしたことはありませんか。
-このURLの記事を読んで、要約して
-私もやったことがあります。ある勉強会にて「その操作が情報漏洩の入り口になりうる」と聞いて、正直ぴんと来ませんでした。読ませているだけなのに、何が漏れるんだろう、と。
-この手法の正体</a:t>
             </a:r>
           </a:p>
         </p:txBody>

</xml_diff>